<commit_message>
fix tiny bit of confusion scaling v identification
</commit_message>
<xml_diff>
--- a/lv_readings/images/lv_scaling.pptx
+++ b/lv_readings/images/lv_scaling.pptx
@@ -265,7 +265,7 @@
           <a:p>
             <a:fld id="{6487BBF2-5813-4A92-ADF4-45C081C37504}" type="datetimeFigureOut">
               <a:rPr lang="en-GB" smtClean="0"/>
-              <a:t>06/11/2025</a:t>
+              <a:t>10/11/2025</a:t>
             </a:fld>
             <a:endParaRPr lang="en-GB"/>
           </a:p>
@@ -465,7 +465,7 @@
           <a:p>
             <a:fld id="{6487BBF2-5813-4A92-ADF4-45C081C37504}" type="datetimeFigureOut">
               <a:rPr lang="en-GB" smtClean="0"/>
-              <a:t>06/11/2025</a:t>
+              <a:t>10/11/2025</a:t>
             </a:fld>
             <a:endParaRPr lang="en-GB"/>
           </a:p>
@@ -675,7 +675,7 @@
           <a:p>
             <a:fld id="{6487BBF2-5813-4A92-ADF4-45C081C37504}" type="datetimeFigureOut">
               <a:rPr lang="en-GB" smtClean="0"/>
-              <a:t>06/11/2025</a:t>
+              <a:t>10/11/2025</a:t>
             </a:fld>
             <a:endParaRPr lang="en-GB"/>
           </a:p>
@@ -875,7 +875,7 @@
           <a:p>
             <a:fld id="{6487BBF2-5813-4A92-ADF4-45C081C37504}" type="datetimeFigureOut">
               <a:rPr lang="en-GB" smtClean="0"/>
-              <a:t>06/11/2025</a:t>
+              <a:t>10/11/2025</a:t>
             </a:fld>
             <a:endParaRPr lang="en-GB"/>
           </a:p>
@@ -1151,7 +1151,7 @@
           <a:p>
             <a:fld id="{6487BBF2-5813-4A92-ADF4-45C081C37504}" type="datetimeFigureOut">
               <a:rPr lang="en-GB" smtClean="0"/>
-              <a:t>06/11/2025</a:t>
+              <a:t>10/11/2025</a:t>
             </a:fld>
             <a:endParaRPr lang="en-GB"/>
           </a:p>
@@ -1419,7 +1419,7 @@
           <a:p>
             <a:fld id="{6487BBF2-5813-4A92-ADF4-45C081C37504}" type="datetimeFigureOut">
               <a:rPr lang="en-GB" smtClean="0"/>
-              <a:t>06/11/2025</a:t>
+              <a:t>10/11/2025</a:t>
             </a:fld>
             <a:endParaRPr lang="en-GB"/>
           </a:p>
@@ -1834,7 +1834,7 @@
           <a:p>
             <a:fld id="{6487BBF2-5813-4A92-ADF4-45C081C37504}" type="datetimeFigureOut">
               <a:rPr lang="en-GB" smtClean="0"/>
-              <a:t>06/11/2025</a:t>
+              <a:t>10/11/2025</a:t>
             </a:fld>
             <a:endParaRPr lang="en-GB"/>
           </a:p>
@@ -1976,7 +1976,7 @@
           <a:p>
             <a:fld id="{6487BBF2-5813-4A92-ADF4-45C081C37504}" type="datetimeFigureOut">
               <a:rPr lang="en-GB" smtClean="0"/>
-              <a:t>06/11/2025</a:t>
+              <a:t>10/11/2025</a:t>
             </a:fld>
             <a:endParaRPr lang="en-GB"/>
           </a:p>
@@ -2089,7 +2089,7 @@
           <a:p>
             <a:fld id="{6487BBF2-5813-4A92-ADF4-45C081C37504}" type="datetimeFigureOut">
               <a:rPr lang="en-GB" smtClean="0"/>
-              <a:t>06/11/2025</a:t>
+              <a:t>10/11/2025</a:t>
             </a:fld>
             <a:endParaRPr lang="en-GB"/>
           </a:p>
@@ -2402,7 +2402,7 @@
           <a:p>
             <a:fld id="{6487BBF2-5813-4A92-ADF4-45C081C37504}" type="datetimeFigureOut">
               <a:rPr lang="en-GB" smtClean="0"/>
-              <a:t>06/11/2025</a:t>
+              <a:t>10/11/2025</a:t>
             </a:fld>
             <a:endParaRPr lang="en-GB"/>
           </a:p>
@@ -2691,7 +2691,7 @@
           <a:p>
             <a:fld id="{6487BBF2-5813-4A92-ADF4-45C081C37504}" type="datetimeFigureOut">
               <a:rPr lang="en-GB" smtClean="0"/>
-              <a:t>06/11/2025</a:t>
+              <a:t>10/11/2025</a:t>
             </a:fld>
             <a:endParaRPr lang="en-GB"/>
           </a:p>
@@ -2934,7 +2934,7 @@
           <a:p>
             <a:fld id="{6487BBF2-5813-4A92-ADF4-45C081C37504}" type="datetimeFigureOut">
               <a:rPr lang="en-GB" smtClean="0"/>
-              <a:t>06/11/2025</a:t>
+              <a:t>10/11/2025</a:t>
             </a:fld>
             <a:endParaRPr lang="en-GB"/>
           </a:p>
@@ -19381,8 +19381,8 @@
           </p:nvSpPr>
           <p:spPr>
             <a:xfrm>
-              <a:off x="3628384" y="1236834"/>
-              <a:ext cx="351378" cy="523220"/>
+              <a:off x="3628383" y="1236835"/>
+              <a:ext cx="351378" cy="559030"/>
             </a:xfrm>
             <a:prstGeom prst="rect">
               <a:avLst/>
@@ -19401,7 +19401,7 @@
                     <a:schemeClr val="accent1"/>
                   </a:solidFill>
                 </a:rPr>
-                <a:t>?</a:t>
+                <a:t>1</a:t>
               </a:r>
             </a:p>
           </p:txBody>
@@ -20689,7 +20689,7 @@
         <p:spPr>
           <a:xfrm>
             <a:off x="9521105" y="1014105"/>
-            <a:ext cx="293224" cy="489704"/>
+            <a:ext cx="293224" cy="523220"/>
           </a:xfrm>
           <a:prstGeom prst="rect">
             <a:avLst/>
@@ -20708,7 +20708,7 @@
                   <a:schemeClr val="accent1"/>
                 </a:solidFill>
               </a:rPr>
-              <a:t>?</a:t>
+              <a:t>1</a:t>
             </a:r>
           </a:p>
         </p:txBody>

</xml_diff>